<commit_message>
Update INST414 week 14 materials
</commit_message>
<xml_diff>
--- a/files/inst414_spring2026/lectures/lecture_14.pptx
+++ b/files/inst414_spring2026/lectures/lecture_14.pptx
@@ -47,6 +47,10 @@
     <p:sldId id="718" r:id="rId38"/>
     <p:sldId id="727" r:id="rId39"/>
     <p:sldId id="729" r:id="rId40"/>
+    <p:sldId id="754" r:id="rId47"/>
+    <p:sldId id="755" r:id="rId48"/>
+    <p:sldId id="756" r:id="rId49"/>
+    <p:sldId id="757" r:id="rId50"/>
     <p:sldId id="731" r:id="rId41"/>
   </p:sldIdLst>
   <p:sldSz cx="12192000" cy="6858000"/>
@@ -13577,6 +13581,340 @@
       </p:transition>
     </mc:Fallback>
   </mc:AlternateContent>
+</p:sld>
+</file>
+
+<file path=ppt/slides/slide41.xml><?xml version="1.0" encoding="utf-8"?>
+<p:sld xmlns:a="http://schemas.openxmlformats.org/drawingml/2006/main" xmlns:p="http://schemas.openxmlformats.org/presentationml/2006/main" xmlns:r="http://schemas.openxmlformats.org/officeDocument/2006/relationships">
+  <p:cSld>
+    <p:spTree>
+      <p:nvGrpSpPr>
+        <p:cNvPr id="1" name=""/>
+        <p:cNvGrpSpPr/>
+        <p:nvPr/>
+      </p:nvGrpSpPr>
+      <p:grpSpPr/>
+      <p:sp>
+        <p:nvSpPr>
+          <p:cNvPr id="2" name="Title 1"/>
+          <p:cNvSpPr>
+            <a:spLocks noGrp="1"/>
+          </p:cNvSpPr>
+          <p:nvPr>
+            <p:ph type="title"/>
+          </p:nvPr>
+        </p:nvSpPr>
+        <p:spPr/>
+        <p:txBody>
+          <a:bodyPr/>
+          <a:lstStyle/>
+          <a:p>
+            <a:r>
+              <a:t>Cost-Benefit Step 1: Start With the Flagged Group</a:t>
+            </a:r>
+          </a:p>
+        </p:txBody>
+      </p:sp>
+      <p:sp>
+        <p:nvSpPr>
+          <p:cNvPr id="3" name="Content Placeholder 2"/>
+          <p:cNvSpPr>
+            <a:spLocks noGrp="1"/>
+          </p:cNvSpPr>
+          <p:nvPr>
+            <p:ph idx="1"/>
+          </p:nvPr>
+        </p:nvSpPr>
+        <p:spPr/>
+        <p:txBody>
+          <a:bodyPr wrap="square"/>
+          <a:lstStyle/>
+          <a:p>
+            <a:pPr/>
+            <a:r>
+              <a:t>The model ranks people by predicted risk.</a:t>
+            </a:r>
+          </a:p>
+          <a:p>
+            <a:pPr/>
+            <a:r>
+              <a:t>Suppose the intervention has K = 500 available slots.</a:t>
+            </a:r>
+          </a:p>
+          <a:p>
+            <a:pPr/>
+            <a:r>
+              <a:t>The agency assigns the intervention to the 500 highest-risk people.</a:t>
+            </a:r>
+          </a:p>
+          <a:p>
+            <a:pPr/>
+            <a:r>
+              <a:t>Among those 500 people, 65 become shooting victims without the intervention.</a:t>
+            </a:r>
+          </a:p>
+          <a:p>
+            <a:pPr/>
+            <a:r>
+              <a:t>That number, 65, is the risk we are trying to reduce.</a:t>
+            </a:r>
+          </a:p>
+        </p:txBody>
+      </p:sp>
+    </p:spTree>
+  </p:cSld>
+  <p:clrMapOvr>
+    <a:masterClrMapping/>
+  </p:clrMapOvr>
+</p:sld>
+</file>
+
+<file path=ppt/slides/slide42.xml><?xml version="1.0" encoding="utf-8"?>
+<p:sld xmlns:a="http://schemas.openxmlformats.org/drawingml/2006/main" xmlns:p="http://schemas.openxmlformats.org/presentationml/2006/main" xmlns:r="http://schemas.openxmlformats.org/officeDocument/2006/relationships">
+  <p:cSld>
+    <p:spTree>
+      <p:nvGrpSpPr>
+        <p:cNvPr id="1" name=""/>
+        <p:cNvGrpSpPr/>
+        <p:nvPr/>
+      </p:nvGrpSpPr>
+      <p:grpSpPr/>
+      <p:sp>
+        <p:nvSpPr>
+          <p:cNvPr id="2" name="Title 1"/>
+          <p:cNvSpPr>
+            <a:spLocks noGrp="1"/>
+          </p:cNvSpPr>
+          <p:nvPr>
+            <p:ph type="title"/>
+          </p:nvPr>
+        </p:nvSpPr>
+        <p:spPr/>
+        <p:txBody>
+          <a:bodyPr/>
+          <a:lstStyle/>
+          <a:p>
+            <a:r>
+              <a:t>Cost-Benefit Step 2: Estimate Prevented Harm</a:t>
+            </a:r>
+          </a:p>
+        </p:txBody>
+      </p:sp>
+      <p:sp>
+        <p:nvSpPr>
+          <p:cNvPr id="3" name="Content Placeholder 2"/>
+          <p:cNvSpPr>
+            <a:spLocks noGrp="1"/>
+          </p:cNvSpPr>
+          <p:nvPr>
+            <p:ph idx="1"/>
+          </p:nvPr>
+        </p:nvSpPr>
+        <p:spPr/>
+        <p:txBody>
+          <a:bodyPr wrap="square"/>
+          <a:lstStyle/>
+          <a:p>
+            <a:pPr/>
+            <a:r>
+              <a:t>Assume the intervention reduces shooting victimization by 50%.</a:t>
+            </a:r>
+          </a:p>
+          <a:p>
+            <a:pPr/>
+            <a:r>
+              <a:t>Expected prevented victimizations = 65 × 0.50.</a:t>
+            </a:r>
+          </a:p>
+          <a:p>
+            <a:pPr/>
+            <a:r>
+              <a:t>65 × 0.50 = 32.5.</a:t>
+            </a:r>
+          </a:p>
+          <a:p>
+            <a:pPr/>
+            <a:r>
+              <a:t>Round to about 33 prevented victimizations.</a:t>
+            </a:r>
+          </a:p>
+          <a:p>
+            <a:pPr/>
+            <a:r>
+              <a:t>This is the expected benefit before converting to dollars.</a:t>
+            </a:r>
+          </a:p>
+        </p:txBody>
+      </p:sp>
+    </p:spTree>
+  </p:cSld>
+  <p:clrMapOvr>
+    <a:masterClrMapping/>
+  </p:clrMapOvr>
+</p:sld>
+</file>
+
+<file path=ppt/slides/slide43.xml><?xml version="1.0" encoding="utf-8"?>
+<p:sld xmlns:a="http://schemas.openxmlformats.org/drawingml/2006/main" xmlns:p="http://schemas.openxmlformats.org/presentationml/2006/main" xmlns:r="http://schemas.openxmlformats.org/officeDocument/2006/relationships">
+  <p:cSld>
+    <p:spTree>
+      <p:nvGrpSpPr>
+        <p:cNvPr id="1" name=""/>
+        <p:cNvGrpSpPr/>
+        <p:nvPr/>
+      </p:nvGrpSpPr>
+      <p:grpSpPr/>
+      <p:sp>
+        <p:nvSpPr>
+          <p:cNvPr id="2" name="Title 1"/>
+          <p:cNvSpPr>
+            <a:spLocks noGrp="1"/>
+          </p:cNvSpPr>
+          <p:nvPr>
+            <p:ph type="title"/>
+          </p:nvPr>
+        </p:nvSpPr>
+        <p:spPr/>
+        <p:txBody>
+          <a:bodyPr/>
+          <a:lstStyle/>
+          <a:p>
+            <a:r>
+              <a:t>Cost-Benefit Step 3: Convert Benefits to Dollars</a:t>
+            </a:r>
+          </a:p>
+        </p:txBody>
+      </p:sp>
+      <p:sp>
+        <p:nvSpPr>
+          <p:cNvPr id="3" name="Content Placeholder 2"/>
+          <p:cNvSpPr>
+            <a:spLocks noGrp="1"/>
+          </p:cNvSpPr>
+          <p:nvPr>
+            <p:ph idx="1"/>
+          </p:nvPr>
+        </p:nvSpPr>
+        <p:spPr/>
+        <p:txBody>
+          <a:bodyPr wrap="square"/>
+          <a:lstStyle/>
+          <a:p>
+            <a:pPr/>
+            <a:r>
+              <a:t>Assume each prevented victimization-year is worth $100,000.</a:t>
+            </a:r>
+          </a:p>
+          <a:p>
+            <a:pPr/>
+            <a:r>
+              <a:t>One-year benefit = 33 × $100,000 = $3.3 million.</a:t>
+            </a:r>
+          </a:p>
+          <a:p>
+            <a:pPr/>
+            <a:r>
+              <a:t>Three-year benefit = 33 × $100,000 × 3 = $9.9 million.</a:t>
+            </a:r>
+          </a:p>
+          <a:p>
+            <a:pPr/>
+            <a:r>
+              <a:t>The longer the benefit lasts, the larger the estimated social benefit.</a:t>
+            </a:r>
+          </a:p>
+        </p:txBody>
+      </p:sp>
+    </p:spTree>
+  </p:cSld>
+  <p:clrMapOvr>
+    <a:masterClrMapping/>
+  </p:clrMapOvr>
+</p:sld>
+</file>
+
+<file path=ppt/slides/slide44.xml><?xml version="1.0" encoding="utf-8"?>
+<p:sld xmlns:a="http://schemas.openxmlformats.org/drawingml/2006/main" xmlns:p="http://schemas.openxmlformats.org/presentationml/2006/main" xmlns:r="http://schemas.openxmlformats.org/officeDocument/2006/relationships">
+  <p:cSld>
+    <p:spTree>
+      <p:nvGrpSpPr>
+        <p:cNvPr id="1" name=""/>
+        <p:cNvGrpSpPr/>
+        <p:nvPr/>
+      </p:nvGrpSpPr>
+      <p:grpSpPr/>
+      <p:sp>
+        <p:nvSpPr>
+          <p:cNvPr id="2" name="Title 1"/>
+          <p:cNvSpPr>
+            <a:spLocks noGrp="1"/>
+          </p:cNvSpPr>
+          <p:nvPr>
+            <p:ph type="title"/>
+          </p:nvPr>
+        </p:nvSpPr>
+        <p:spPr/>
+        <p:txBody>
+          <a:bodyPr/>
+          <a:lstStyle/>
+          <a:p>
+            <a:r>
+              <a:t>Cost-Benefit Step 4: Compare Benefits to Costs</a:t>
+            </a:r>
+          </a:p>
+        </p:txBody>
+      </p:sp>
+      <p:sp>
+        <p:nvSpPr>
+          <p:cNvPr id="3" name="Content Placeholder 2"/>
+          <p:cNvSpPr>
+            <a:spLocks noGrp="1"/>
+          </p:cNvSpPr>
+          <p:nvPr>
+            <p:ph idx="1"/>
+          </p:nvPr>
+        </p:nvSpPr>
+        <p:spPr/>
+        <p:txBody>
+          <a:bodyPr wrap="square"/>
+          <a:lstStyle/>
+          <a:p>
+            <a:pPr/>
+            <a:r>
+              <a:t>Assume the program costs $20,000 per person.</a:t>
+            </a:r>
+          </a:p>
+          <a:p>
+            <a:pPr/>
+            <a:r>
+              <a:t>Program cost = 500 × $20,000 = $10 million.</a:t>
+            </a:r>
+          </a:p>
+          <a:p>
+            <a:pPr/>
+            <a:r>
+              <a:t>Net benefit, 1 year = $3.3 million − $10 million = −$6.7 million.</a:t>
+            </a:r>
+          </a:p>
+          <a:p>
+            <a:pPr/>
+            <a:r>
+              <a:t>Net benefit, 3 years = $9.9 million − $10 million = −$0.1 million.</a:t>
+            </a:r>
+          </a:p>
+          <a:p>
+            <a:pPr/>
+            <a:r>
+              <a:t>The recommendation depends on the assumptions about effectiveness, cost, and duration.</a:t>
+            </a:r>
+          </a:p>
+        </p:txBody>
+      </p:sp>
+    </p:spTree>
+  </p:cSld>
+  <p:clrMapOvr>
+    <a:masterClrMapping/>
+  </p:clrMapOvr>
 </p:sld>
 </file>
 

</xml_diff>

<commit_message>
Add INST414 cost benefit explainer
</commit_message>
<xml_diff>
--- a/files/inst414_spring2026/lectures/lecture_14.pptx
+++ b/files/inst414_spring2026/lectures/lecture_14.pptx
@@ -5,10 +5,16 @@
     <p:sldMasterId id="2147483648" r:id="rId1"/>
   </p:sldMasterIdLst>
   <p:notesMasterIdLst>
-    <p:notesMasterId r:id="rId42"/>
+    <p:notesMasterId r:id="rId49"/>
   </p:notesMasterIdLst>
   <p:sldIdLst>
     <p:sldId id="732" r:id="rId2"/>
+    <p:sldId id="761" r:id="rId54"/>
+    <p:sldId id="762" r:id="rId55"/>
+    <p:sldId id="763" r:id="rId56"/>
+    <p:sldId id="764" r:id="rId57"/>
+    <p:sldId id="765" r:id="rId58"/>
+    <p:sldId id="766" r:id="rId59"/>
     <p:sldId id="703" r:id="rId3"/>
     <p:sldId id="274" r:id="rId4"/>
     <p:sldId id="736" r:id="rId5"/>
@@ -47,11 +53,14 @@
     <p:sldId id="718" r:id="rId38"/>
     <p:sldId id="727" r:id="rId39"/>
     <p:sldId id="729" r:id="rId40"/>
-    <p:sldId id="754" r:id="rId47"/>
-    <p:sldId id="755" r:id="rId48"/>
-    <p:sldId id="756" r:id="rId49"/>
-    <p:sldId id="757" r:id="rId50"/>
-    <p:sldId id="731" r:id="rId41"/>
+    <p:sldId id="758" r:id="rId41"/>
+    <p:sldId id="759" r:id="rId42"/>
+    <p:sldId id="760" r:id="rId43"/>
+    <p:sldId id="754" r:id="rId44"/>
+    <p:sldId id="755" r:id="rId45"/>
+    <p:sldId id="756" r:id="rId46"/>
+    <p:sldId id="757" r:id="rId47"/>
+    <p:sldId id="731" r:id="rId48"/>
   </p:sldIdLst>
   <p:sldSz cx="12192000" cy="6858000"/>
   <p:notesSz cx="6858000" cy="9144000"/>
@@ -240,7 +249,7 @@
           <a:p>
             <a:fld id="{B9D9C62C-948D-496E-BC05-25DCCC248003}" type="datetimeFigureOut">
               <a:rPr lang="en-US" smtClean="0"/>
-              <a:t>12/1/2022</a:t>
+              <a:t>5/8/2026</a:t>
             </a:fld>
             <a:endParaRPr lang="en-US"/>
           </a:p>
@@ -667,7 +676,10 @@
           <a:bodyPr anchor="b"/>
           <a:lstStyle>
             <a:lvl1pPr algn="ctr">
-              <a:defRPr sz="6000"/>
+              <a:defRPr sz="6000">
+                <a:latin typeface="Cambria" panose="02040503050406030204" pitchFamily="18" charset="0"/>
+                <a:ea typeface="Cambria" panose="02040503050406030204" pitchFamily="18" charset="0"/>
+              </a:defRPr>
             </a:lvl1pPr>
           </a:lstStyle>
           <a:p>
@@ -705,7 +717,10 @@
           <a:lstStyle>
             <a:lvl1pPr marL="0" indent="0" algn="ctr">
               <a:buNone/>
-              <a:defRPr sz="2400"/>
+              <a:defRPr sz="2400">
+                <a:latin typeface="Cambria" panose="02040503050406030204" pitchFamily="18" charset="0"/>
+                <a:ea typeface="Cambria" panose="02040503050406030204" pitchFamily="18" charset="0"/>
+              </a:defRPr>
             </a:lvl1pPr>
             <a:lvl2pPr marL="457200" indent="0" algn="ctr">
               <a:buNone/>
@@ -767,11 +782,19 @@
         <p:spPr/>
         <p:txBody>
           <a:bodyPr/>
-          <a:lstStyle/>
+          <a:lstStyle>
+            <a:lvl1pPr>
+              <a:defRPr>
+                <a:latin typeface="Cambria" panose="02040503050406030204" pitchFamily="18" charset="0"/>
+                <a:ea typeface="Cambria" panose="02040503050406030204" pitchFamily="18" charset="0"/>
+              </a:defRPr>
+            </a:lvl1pPr>
+          </a:lstStyle>
           <a:p>
             <a:fld id="{52A4A5FF-00F1-4B9C-80DF-298EB6626127}" type="datetimeFigureOut">
               <a:rPr lang="en-US" smtClean="0"/>
-              <a:t>12/1/2022</a:t>
+              <a:pPr/>
+              <a:t>5/8/2026</a:t>
             </a:fld>
             <a:endParaRPr lang="en-US"/>
           </a:p>
@@ -796,7 +819,14 @@
         <p:spPr/>
         <p:txBody>
           <a:bodyPr/>
-          <a:lstStyle/>
+          <a:lstStyle>
+            <a:lvl1pPr>
+              <a:defRPr>
+                <a:latin typeface="Cambria" panose="02040503050406030204" pitchFamily="18" charset="0"/>
+                <a:ea typeface="Cambria" panose="02040503050406030204" pitchFamily="18" charset="0"/>
+              </a:defRPr>
+            </a:lvl1pPr>
+          </a:lstStyle>
           <a:p>
             <a:endParaRPr lang="en-US"/>
           </a:p>
@@ -821,10 +851,18 @@
         <p:spPr/>
         <p:txBody>
           <a:bodyPr/>
-          <a:lstStyle/>
+          <a:lstStyle>
+            <a:lvl1pPr>
+              <a:defRPr>
+                <a:latin typeface="Cambria" panose="02040503050406030204" pitchFamily="18" charset="0"/>
+                <a:ea typeface="Cambria" panose="02040503050406030204" pitchFamily="18" charset="0"/>
+              </a:defRPr>
+            </a:lvl1pPr>
+          </a:lstStyle>
           <a:p>
             <a:fld id="{460A0532-F395-4844-A4A9-A77B31D44342}" type="slidenum">
               <a:rPr lang="en-US" smtClean="0"/>
+              <a:pPr/>
               <a:t>‹#›</a:t>
             </a:fld>
             <a:endParaRPr lang="en-US"/>
@@ -969,7 +1007,7 @@
           <a:p>
             <a:fld id="{52A4A5FF-00F1-4B9C-80DF-298EB6626127}" type="datetimeFigureOut">
               <a:rPr lang="en-US" smtClean="0"/>
-              <a:t>12/1/2022</a:t>
+              <a:t>5/8/2026</a:t>
             </a:fld>
             <a:endParaRPr lang="en-US"/>
           </a:p>
@@ -1177,7 +1215,7 @@
           <a:p>
             <a:fld id="{52A4A5FF-00F1-4B9C-80DF-298EB6626127}" type="datetimeFigureOut">
               <a:rPr lang="en-US" smtClean="0"/>
-              <a:t>12/1/2022</a:t>
+              <a:t>5/8/2026</a:t>
             </a:fld>
             <a:endParaRPr lang="en-US"/>
           </a:p>
@@ -1286,7 +1324,14 @@
         <p:spPr/>
         <p:txBody>
           <a:bodyPr/>
-          <a:lstStyle/>
+          <a:lstStyle>
+            <a:lvl1pPr>
+              <a:defRPr>
+                <a:latin typeface="Cambria" panose="02040503050406030204" pitchFamily="18" charset="0"/>
+                <a:ea typeface="Cambria" panose="02040503050406030204" pitchFamily="18" charset="0"/>
+              </a:defRPr>
+            </a:lvl1pPr>
+          </a:lstStyle>
           <a:p>
             <a:r>
               <a:rPr lang="en-US"/>
@@ -1314,7 +1359,38 @@
         <p:spPr/>
         <p:txBody>
           <a:bodyPr/>
-          <a:lstStyle/>
+          <a:lstStyle>
+            <a:lvl1pPr>
+              <a:defRPr>
+                <a:latin typeface="Cambria" panose="02040503050406030204" pitchFamily="18" charset="0"/>
+                <a:ea typeface="Cambria" panose="02040503050406030204" pitchFamily="18" charset="0"/>
+              </a:defRPr>
+            </a:lvl1pPr>
+            <a:lvl2pPr>
+              <a:defRPr>
+                <a:latin typeface="Cambria" panose="02040503050406030204" pitchFamily="18" charset="0"/>
+                <a:ea typeface="Cambria" panose="02040503050406030204" pitchFamily="18" charset="0"/>
+              </a:defRPr>
+            </a:lvl2pPr>
+            <a:lvl3pPr>
+              <a:defRPr>
+                <a:latin typeface="Cambria" panose="02040503050406030204" pitchFamily="18" charset="0"/>
+                <a:ea typeface="Cambria" panose="02040503050406030204" pitchFamily="18" charset="0"/>
+              </a:defRPr>
+            </a:lvl3pPr>
+            <a:lvl4pPr>
+              <a:defRPr>
+                <a:latin typeface="Cambria" panose="02040503050406030204" pitchFamily="18" charset="0"/>
+                <a:ea typeface="Cambria" panose="02040503050406030204" pitchFamily="18" charset="0"/>
+              </a:defRPr>
+            </a:lvl4pPr>
+            <a:lvl5pPr>
+              <a:defRPr>
+                <a:latin typeface="Cambria" panose="02040503050406030204" pitchFamily="18" charset="0"/>
+                <a:ea typeface="Cambria" panose="02040503050406030204" pitchFamily="18" charset="0"/>
+              </a:defRPr>
+            </a:lvl5pPr>
+          </a:lstStyle>
           <a:p>
             <a:pPr lvl="0"/>
             <a:r>
@@ -1371,11 +1447,19 @@
         <p:spPr/>
         <p:txBody>
           <a:bodyPr/>
-          <a:lstStyle/>
+          <a:lstStyle>
+            <a:lvl1pPr>
+              <a:defRPr>
+                <a:latin typeface="Cambria" panose="02040503050406030204" pitchFamily="18" charset="0"/>
+                <a:ea typeface="Cambria" panose="02040503050406030204" pitchFamily="18" charset="0"/>
+              </a:defRPr>
+            </a:lvl1pPr>
+          </a:lstStyle>
           <a:p>
             <a:fld id="{52A4A5FF-00F1-4B9C-80DF-298EB6626127}" type="datetimeFigureOut">
               <a:rPr lang="en-US" smtClean="0"/>
-              <a:t>12/1/2022</a:t>
+              <a:pPr/>
+              <a:t>5/8/2026</a:t>
             </a:fld>
             <a:endParaRPr lang="en-US"/>
           </a:p>
@@ -1400,7 +1484,14 @@
         <p:spPr/>
         <p:txBody>
           <a:bodyPr/>
-          <a:lstStyle/>
+          <a:lstStyle>
+            <a:lvl1pPr>
+              <a:defRPr>
+                <a:latin typeface="Cambria" panose="02040503050406030204" pitchFamily="18" charset="0"/>
+                <a:ea typeface="Cambria" panose="02040503050406030204" pitchFamily="18" charset="0"/>
+              </a:defRPr>
+            </a:lvl1pPr>
+          </a:lstStyle>
           <a:p>
             <a:endParaRPr lang="en-US"/>
           </a:p>
@@ -1425,10 +1516,18 @@
         <p:spPr/>
         <p:txBody>
           <a:bodyPr/>
-          <a:lstStyle/>
+          <a:lstStyle>
+            <a:lvl1pPr>
+              <a:defRPr>
+                <a:latin typeface="Cambria" panose="02040503050406030204" pitchFamily="18" charset="0"/>
+                <a:ea typeface="Cambria" panose="02040503050406030204" pitchFamily="18" charset="0"/>
+              </a:defRPr>
+            </a:lvl1pPr>
+          </a:lstStyle>
           <a:p>
             <a:fld id="{460A0532-F395-4844-A4A9-A77B31D44342}" type="slidenum">
               <a:rPr lang="en-US" smtClean="0"/>
+              <a:pPr/>
               <a:t>‹#›</a:t>
             </a:fld>
             <a:endParaRPr lang="en-US"/>
@@ -1491,7 +1590,10 @@
           <a:bodyPr anchor="b"/>
           <a:lstStyle>
             <a:lvl1pPr>
-              <a:defRPr sz="6000"/>
+              <a:defRPr sz="6000">
+                <a:latin typeface="Cambria" panose="02040503050406030204" pitchFamily="18" charset="0"/>
+                <a:ea typeface="Cambria" panose="02040503050406030204" pitchFamily="18" charset="0"/>
+              </a:defRPr>
             </a:lvl1pPr>
           </a:lstStyle>
           <a:p>
@@ -1535,6 +1637,8 @@
                     <a:tint val="75000"/>
                   </a:schemeClr>
                 </a:solidFill>
+                <a:latin typeface="Cambria" panose="02040503050406030204" pitchFamily="18" charset="0"/>
+                <a:ea typeface="Cambria" panose="02040503050406030204" pitchFamily="18" charset="0"/>
               </a:defRPr>
             </a:lvl1pPr>
             <a:lvl2pPr marL="457200" indent="0">
@@ -1646,11 +1750,19 @@
         <p:spPr/>
         <p:txBody>
           <a:bodyPr/>
-          <a:lstStyle/>
+          <a:lstStyle>
+            <a:lvl1pPr>
+              <a:defRPr>
+                <a:latin typeface="Cambria" panose="02040503050406030204" pitchFamily="18" charset="0"/>
+                <a:ea typeface="Cambria" panose="02040503050406030204" pitchFamily="18" charset="0"/>
+              </a:defRPr>
+            </a:lvl1pPr>
+          </a:lstStyle>
           <a:p>
             <a:fld id="{52A4A5FF-00F1-4B9C-80DF-298EB6626127}" type="datetimeFigureOut">
               <a:rPr lang="en-US" smtClean="0"/>
-              <a:t>12/1/2022</a:t>
+              <a:pPr/>
+              <a:t>5/8/2026</a:t>
             </a:fld>
             <a:endParaRPr lang="en-US"/>
           </a:p>
@@ -1675,7 +1787,14 @@
         <p:spPr/>
         <p:txBody>
           <a:bodyPr/>
-          <a:lstStyle/>
+          <a:lstStyle>
+            <a:lvl1pPr>
+              <a:defRPr>
+                <a:latin typeface="Cambria" panose="02040503050406030204" pitchFamily="18" charset="0"/>
+                <a:ea typeface="Cambria" panose="02040503050406030204" pitchFamily="18" charset="0"/>
+              </a:defRPr>
+            </a:lvl1pPr>
+          </a:lstStyle>
           <a:p>
             <a:endParaRPr lang="en-US"/>
           </a:p>
@@ -1700,10 +1819,18 @@
         <p:spPr/>
         <p:txBody>
           <a:bodyPr/>
-          <a:lstStyle/>
+          <a:lstStyle>
+            <a:lvl1pPr>
+              <a:defRPr>
+                <a:latin typeface="Cambria" panose="02040503050406030204" pitchFamily="18" charset="0"/>
+                <a:ea typeface="Cambria" panose="02040503050406030204" pitchFamily="18" charset="0"/>
+              </a:defRPr>
+            </a:lvl1pPr>
+          </a:lstStyle>
           <a:p>
             <a:fld id="{460A0532-F395-4844-A4A9-A77B31D44342}" type="slidenum">
               <a:rPr lang="en-US" smtClean="0"/>
+              <a:pPr/>
               <a:t>‹#›</a:t>
             </a:fld>
             <a:endParaRPr lang="en-US"/>
@@ -1915,7 +2042,7 @@
           <a:p>
             <a:fld id="{52A4A5FF-00F1-4B9C-80DF-298EB6626127}" type="datetimeFigureOut">
               <a:rPr lang="en-US" smtClean="0"/>
-              <a:t>12/1/2022</a:t>
+              <a:t>5/8/2026</a:t>
             </a:fld>
             <a:endParaRPr lang="en-US"/>
           </a:p>
@@ -2327,7 +2454,7 @@
           <a:p>
             <a:fld id="{52A4A5FF-00F1-4B9C-80DF-298EB6626127}" type="datetimeFigureOut">
               <a:rPr lang="en-US" smtClean="0"/>
-              <a:t>12/1/2022</a:t>
+              <a:t>5/8/2026</a:t>
             </a:fld>
             <a:endParaRPr lang="en-US"/>
           </a:p>
@@ -2468,7 +2595,7 @@
           <a:p>
             <a:fld id="{52A4A5FF-00F1-4B9C-80DF-298EB6626127}" type="datetimeFigureOut">
               <a:rPr lang="en-US" smtClean="0"/>
-              <a:t>12/1/2022</a:t>
+              <a:t>5/8/2026</a:t>
             </a:fld>
             <a:endParaRPr lang="en-US"/>
           </a:p>
@@ -2581,7 +2708,7 @@
           <a:p>
             <a:fld id="{52A4A5FF-00F1-4B9C-80DF-298EB6626127}" type="datetimeFigureOut">
               <a:rPr lang="en-US" smtClean="0"/>
-              <a:t>12/1/2022</a:t>
+              <a:t>5/8/2026</a:t>
             </a:fld>
             <a:endParaRPr lang="en-US"/>
           </a:p>
@@ -2892,7 +3019,7 @@
           <a:p>
             <a:fld id="{52A4A5FF-00F1-4B9C-80DF-298EB6626127}" type="datetimeFigureOut">
               <a:rPr lang="en-US" smtClean="0"/>
-              <a:t>12/1/2022</a:t>
+              <a:t>5/8/2026</a:t>
             </a:fld>
             <a:endParaRPr lang="en-US"/>
           </a:p>
@@ -3180,7 +3307,7 @@
           <a:p>
             <a:fld id="{52A4A5FF-00F1-4B9C-80DF-298EB6626127}" type="datetimeFigureOut">
               <a:rPr lang="en-US" smtClean="0"/>
-              <a:t>12/1/2022</a:t>
+              <a:t>5/8/2026</a:t>
             </a:fld>
             <a:endParaRPr lang="en-US"/>
           </a:p>
@@ -3421,7 +3548,7 @@
           <a:p>
             <a:fld id="{52A4A5FF-00F1-4B9C-80DF-298EB6626127}" type="datetimeFigureOut">
               <a:rPr lang="en-US" smtClean="0"/>
-              <a:t>12/1/2022</a:t>
+              <a:t>5/8/2026</a:t>
             </a:fld>
             <a:endParaRPr lang="en-US"/>
           </a:p>
@@ -3868,11 +3995,7 @@
           <a:p>
             <a:r>
               <a:rPr lang="en-US" dirty="0"/>
-              <a:t>INST 414: Data </a:t>
-            </a:r>
-            <a:r>
-              <a:rPr lang="en-US"/>
-              <a:t>Science Techniques</a:t>
+              <a:t>INST 414: Data Science Techniques</a:t>
             </a:r>
             <a:br>
               <a:rPr lang="en-US" dirty="0"/>
@@ -3886,28 +4009,7 @@
             </a:br>
             <a:r>
               <a:rPr lang="en-US" sz="4900" dirty="0"/>
-              <a:t>Lecture 14</a:t>
-            </a:r>
-            <a:br>
-              <a:rPr lang="en-US" sz="4900" dirty="0"/>
-            </a:br>
-            <a:r>
-              <a:rPr lang="en-US" sz="4900" dirty="0"/>
-              <a:t>The Predictive </a:t>
-            </a:r>
-            <a:br>
-              <a:rPr lang="en-US" sz="4900" dirty="0"/>
-            </a:br>
-            <a:r>
-              <a:rPr lang="en-US" sz="4900" dirty="0"/>
-              <a:t>Utility of </a:t>
-            </a:r>
-            <a:br>
-              <a:rPr lang="en-US" sz="4900" dirty="0"/>
-            </a:br>
-            <a:r>
-              <a:rPr lang="en-US" sz="4900" dirty="0"/>
-              <a:t>Arrest Records</a:t>
+              <a:t>Assessing Real-World Impact</a:t>
             </a:r>
             <a:endParaRPr lang="en-US" dirty="0"/>
           </a:p>
@@ -9515,14 +9617,8 @@
           </a:bodyPr>
           <a:lstStyle/>
           <a:p>
-            <a:pPr algn="ctr"/>
-            <a:r>
-              <a:rPr lang="en-US" dirty="0">
-                <a:solidFill>
-                  <a:schemeClr val="bg1"/>
-                </a:solidFill>
-              </a:rPr>
-              <a:t>Selective Labels Problem</a:t>
+            <a:r>
+              <a:t>Problem 1: Selective Labels</a:t>
             </a:r>
           </a:p>
         </p:txBody>
@@ -10725,7 +10821,7 @@
         </p:spPr>
         <p:txBody>
           <a:bodyPr>
-            <a:normAutofit lnSpcReduction="10000"/>
+            <a:normAutofit fontScale="92500"/>
           </a:bodyPr>
           <a:lstStyle/>
           <a:p>
@@ -10984,7 +11080,7 @@
         </p:spPr>
         <p:txBody>
           <a:bodyPr>
-            <a:normAutofit fontScale="85000" lnSpcReduction="10000"/>
+            <a:normAutofit fontScale="85000" lnSpcReduction="20000"/>
           </a:bodyPr>
           <a:lstStyle/>
           <a:p>
@@ -13481,6 +13577,678 @@
           <p:cNvPr id="2" name="Title 1">
             <a:extLst>
               <a:ext uri="{FF2B5EF4-FFF2-40B4-BE49-F238E27FC236}">
+                <a16:creationId xmlns:a16="http://schemas.microsoft.com/office/drawing/2014/main" id="{7E40076B-14F3-492E-54EF-6BF1B632F570}"/>
+              </a:ext>
+            </a:extLst>
+          </p:cNvPr>
+          <p:cNvSpPr>
+            <a:spLocks noGrp="1"/>
+          </p:cNvSpPr>
+          <p:nvPr>
+            <p:ph type="title"/>
+          </p:nvPr>
+        </p:nvSpPr>
+        <p:spPr/>
+        <p:txBody>
+          <a:bodyPr/>
+          <a:lstStyle/>
+          <a:p>
+            <a:r>
+              <a:rPr lang="en-US" dirty="0"/>
+              <a:t>Outreach vs Algorithm</a:t>
+            </a:r>
+          </a:p>
+        </p:txBody>
+      </p:sp>
+      <p:sp>
+        <p:nvSpPr>
+          <p:cNvPr id="3" name="Content Placeholder 2">
+            <a:extLst>
+              <a:ext uri="{FF2B5EF4-FFF2-40B4-BE49-F238E27FC236}">
+                <a16:creationId xmlns:a16="http://schemas.microsoft.com/office/drawing/2014/main" id="{A9E4F026-EAD1-5B60-2E8C-679974770AAB}"/>
+              </a:ext>
+            </a:extLst>
+          </p:cNvPr>
+          <p:cNvSpPr>
+            <a:spLocks noGrp="1"/>
+          </p:cNvSpPr>
+          <p:nvPr>
+            <p:ph idx="1"/>
+          </p:nvPr>
+        </p:nvSpPr>
+        <p:spPr>
+          <a:xfrm>
+            <a:off x="838200" y="1825625"/>
+            <a:ext cx="4304251" cy="4351338"/>
+          </a:xfrm>
+        </p:spPr>
+        <p:txBody>
+          <a:bodyPr/>
+          <a:lstStyle/>
+          <a:p>
+            <a:r>
+              <a:rPr lang="en-US" dirty="0"/>
+              <a:t>Distribution of risk scores by pathway</a:t>
+            </a:r>
+          </a:p>
+        </p:txBody>
+      </p:sp>
+      <p:pic>
+        <p:nvPicPr>
+          <p:cNvPr id="5" name="Picture 4">
+            <a:extLst>
+              <a:ext uri="{FF2B5EF4-FFF2-40B4-BE49-F238E27FC236}">
+                <a16:creationId xmlns:a16="http://schemas.microsoft.com/office/drawing/2014/main" id="{67DA05D5-167A-2AA5-CEC0-02936015BB8F}"/>
+              </a:ext>
+            </a:extLst>
+          </p:cNvPr>
+          <p:cNvPicPr>
+            <a:picLocks noChangeAspect="1"/>
+          </p:cNvPicPr>
+          <p:nvPr/>
+        </p:nvPicPr>
+        <p:blipFill>
+          <a:blip r:embed="rId2"/>
+          <a:stretch>
+            <a:fillRect/>
+          </a:stretch>
+        </p:blipFill>
+        <p:spPr>
+          <a:xfrm>
+            <a:off x="5139777" y="1917904"/>
+            <a:ext cx="6392167" cy="4115374"/>
+          </a:xfrm>
+          <a:prstGeom prst="rect">
+            <a:avLst/>
+          </a:prstGeom>
+        </p:spPr>
+      </p:pic>
+    </p:spTree>
+    <p:extLst>
+      <p:ext uri="{BB962C8B-B14F-4D97-AF65-F5344CB8AC3E}">
+        <p14:creationId xmlns:p14="http://schemas.microsoft.com/office/powerpoint/2010/main" val="3472875438"/>
+      </p:ext>
+    </p:extLst>
+  </p:cSld>
+  <p:clrMapOvr>
+    <a:masterClrMapping/>
+  </p:clrMapOvr>
+</p:sld>
+</file>
+
+<file path=ppt/slides/slide41.xml><?xml version="1.0" encoding="utf-8"?>
+<p:sld xmlns:a="http://schemas.openxmlformats.org/drawingml/2006/main" xmlns:r="http://schemas.openxmlformats.org/officeDocument/2006/relationships" xmlns:p="http://schemas.openxmlformats.org/presentationml/2006/main">
+  <p:cSld>
+    <p:spTree>
+      <p:nvGrpSpPr>
+        <p:cNvPr id="1" name=""/>
+        <p:cNvGrpSpPr/>
+        <p:nvPr/>
+      </p:nvGrpSpPr>
+      <p:grpSpPr>
+        <a:xfrm>
+          <a:off x="0" y="0"/>
+          <a:ext cx="0" cy="0"/>
+          <a:chOff x="0" y="0"/>
+          <a:chExt cx="0" cy="0"/>
+        </a:xfrm>
+      </p:grpSpPr>
+      <p:sp>
+        <p:nvSpPr>
+          <p:cNvPr id="2" name="Title 1">
+            <a:extLst>
+              <a:ext uri="{FF2B5EF4-FFF2-40B4-BE49-F238E27FC236}">
+                <a16:creationId xmlns:a16="http://schemas.microsoft.com/office/drawing/2014/main" id="{7E40076B-14F3-492E-54EF-6BF1B632F570}"/>
+              </a:ext>
+            </a:extLst>
+          </p:cNvPr>
+          <p:cNvSpPr>
+            <a:spLocks noGrp="1"/>
+          </p:cNvSpPr>
+          <p:nvPr>
+            <p:ph type="title"/>
+          </p:nvPr>
+        </p:nvSpPr>
+        <p:spPr/>
+        <p:txBody>
+          <a:bodyPr/>
+          <a:lstStyle/>
+          <a:p>
+            <a:r>
+              <a:rPr lang="en-US" dirty="0"/>
+              <a:t>Outreach vs Algorithm</a:t>
+            </a:r>
+          </a:p>
+        </p:txBody>
+      </p:sp>
+      <p:sp>
+        <p:nvSpPr>
+          <p:cNvPr id="3" name="Content Placeholder 2">
+            <a:extLst>
+              <a:ext uri="{FF2B5EF4-FFF2-40B4-BE49-F238E27FC236}">
+                <a16:creationId xmlns:a16="http://schemas.microsoft.com/office/drawing/2014/main" id="{A9E4F026-EAD1-5B60-2E8C-679974770AAB}"/>
+              </a:ext>
+            </a:extLst>
+          </p:cNvPr>
+          <p:cNvSpPr>
+            <a:spLocks noGrp="1"/>
+          </p:cNvSpPr>
+          <p:nvPr>
+            <p:ph idx="1"/>
+          </p:nvPr>
+        </p:nvSpPr>
+        <p:spPr>
+          <a:xfrm>
+            <a:off x="838200" y="1825625"/>
+            <a:ext cx="8909807" cy="925964"/>
+          </a:xfrm>
+        </p:spPr>
+        <p:txBody>
+          <a:bodyPr/>
+          <a:lstStyle/>
+          <a:p>
+            <a:r>
+              <a:rPr lang="en-US" dirty="0"/>
+              <a:t>Distribution of risk scores by pathway</a:t>
+            </a:r>
+          </a:p>
+        </p:txBody>
+      </p:sp>
+      <p:pic>
+        <p:nvPicPr>
+          <p:cNvPr id="6" name="Picture 5">
+            <a:extLst>
+              <a:ext uri="{FF2B5EF4-FFF2-40B4-BE49-F238E27FC236}">
+                <a16:creationId xmlns:a16="http://schemas.microsoft.com/office/drawing/2014/main" id="{F090553E-8CF4-469A-CB81-2C583897149F}"/>
+              </a:ext>
+            </a:extLst>
+          </p:cNvPr>
+          <p:cNvPicPr>
+            <a:picLocks noChangeAspect="1"/>
+          </p:cNvPicPr>
+          <p:nvPr/>
+        </p:nvPicPr>
+        <p:blipFill>
+          <a:blip r:embed="rId2"/>
+          <a:stretch>
+            <a:fillRect/>
+          </a:stretch>
+        </p:blipFill>
+        <p:spPr>
+          <a:xfrm>
+            <a:off x="265886" y="1912891"/>
+            <a:ext cx="11660227" cy="3924848"/>
+          </a:xfrm>
+          <a:prstGeom prst="rect">
+            <a:avLst/>
+          </a:prstGeom>
+        </p:spPr>
+      </p:pic>
+    </p:spTree>
+    <p:extLst>
+      <p:ext uri="{BB962C8B-B14F-4D97-AF65-F5344CB8AC3E}">
+        <p14:creationId xmlns:p14="http://schemas.microsoft.com/office/powerpoint/2010/main" val="3125123144"/>
+      </p:ext>
+    </p:extLst>
+  </p:cSld>
+  <p:clrMapOvr>
+    <a:masterClrMapping/>
+  </p:clrMapOvr>
+</p:sld>
+</file>
+
+<file path=ppt/slides/slide42.xml><?xml version="1.0" encoding="utf-8"?>
+<p:sld xmlns:a="http://schemas.openxmlformats.org/drawingml/2006/main" xmlns:r="http://schemas.openxmlformats.org/officeDocument/2006/relationships" xmlns:p="http://schemas.openxmlformats.org/presentationml/2006/main">
+  <p:cSld>
+    <p:spTree>
+      <p:nvGrpSpPr>
+        <p:cNvPr id="1" name=""/>
+        <p:cNvGrpSpPr/>
+        <p:nvPr/>
+      </p:nvGrpSpPr>
+      <p:grpSpPr>
+        <a:xfrm>
+          <a:off x="0" y="0"/>
+          <a:ext cx="0" cy="0"/>
+          <a:chOff x="0" y="0"/>
+          <a:chExt cx="0" cy="0"/>
+        </a:xfrm>
+      </p:grpSpPr>
+      <p:sp>
+        <p:nvSpPr>
+          <p:cNvPr id="2" name="Title 1">
+            <a:extLst>
+              <a:ext uri="{FF2B5EF4-FFF2-40B4-BE49-F238E27FC236}">
+                <a16:creationId xmlns:a16="http://schemas.microsoft.com/office/drawing/2014/main" id="{5EC01D99-1825-2766-0926-A834934EB7E9}"/>
+              </a:ext>
+            </a:extLst>
+          </p:cNvPr>
+          <p:cNvSpPr>
+            <a:spLocks noGrp="1"/>
+          </p:cNvSpPr>
+          <p:nvPr>
+            <p:ph type="title"/>
+          </p:nvPr>
+        </p:nvSpPr>
+        <p:spPr/>
+        <p:txBody>
+          <a:bodyPr/>
+          <a:lstStyle/>
+          <a:p>
+            <a:r>
+              <a:rPr lang="en-US" dirty="0"/>
+              <a:t>Outreach vs Algorithm</a:t>
+            </a:r>
+          </a:p>
+        </p:txBody>
+      </p:sp>
+      <p:pic>
+        <p:nvPicPr>
+          <p:cNvPr id="5" name="Content Placeholder 4">
+            <a:extLst>
+              <a:ext uri="{FF2B5EF4-FFF2-40B4-BE49-F238E27FC236}">
+                <a16:creationId xmlns:a16="http://schemas.microsoft.com/office/drawing/2014/main" id="{60A12756-F2B7-7BAD-0D34-BB3FB2F2ED2E}"/>
+              </a:ext>
+            </a:extLst>
+          </p:cNvPr>
+          <p:cNvPicPr>
+            <a:picLocks noGrp="1" noChangeAspect="1"/>
+          </p:cNvPicPr>
+          <p:nvPr>
+            <p:ph idx="1"/>
+          </p:nvPr>
+        </p:nvPicPr>
+        <p:blipFill>
+          <a:blip r:embed="rId2"/>
+          <a:stretch>
+            <a:fillRect/>
+          </a:stretch>
+        </p:blipFill>
+        <p:spPr>
+          <a:xfrm>
+            <a:off x="838200" y="2050550"/>
+            <a:ext cx="10515600" cy="3901488"/>
+          </a:xfrm>
+        </p:spPr>
+      </p:pic>
+    </p:spTree>
+    <p:extLst>
+      <p:ext uri="{BB962C8B-B14F-4D97-AF65-F5344CB8AC3E}">
+        <p14:creationId xmlns:p14="http://schemas.microsoft.com/office/powerpoint/2010/main" val="1747587916"/>
+      </p:ext>
+    </p:extLst>
+  </p:cSld>
+  <p:clrMapOvr>
+    <a:masterClrMapping/>
+  </p:clrMapOvr>
+</p:sld>
+</file>
+
+<file path=ppt/slides/slide43.xml><?xml version="1.0" encoding="utf-8"?>
+<p:sld xmlns:a="http://schemas.openxmlformats.org/drawingml/2006/main" xmlns:r="http://schemas.openxmlformats.org/officeDocument/2006/relationships" xmlns:p="http://schemas.openxmlformats.org/presentationml/2006/main">
+  <p:cSld>
+    <p:spTree>
+      <p:nvGrpSpPr>
+        <p:cNvPr id="1" name=""/>
+        <p:cNvGrpSpPr/>
+        <p:nvPr/>
+      </p:nvGrpSpPr>
+      <p:grpSpPr>
+        <a:xfrm>
+          <a:off x="0" y="0"/>
+          <a:ext cx="0" cy="0"/>
+          <a:chOff x="0" y="0"/>
+          <a:chExt cx="0" cy="0"/>
+        </a:xfrm>
+      </p:grpSpPr>
+      <p:sp>
+        <p:nvSpPr>
+          <p:cNvPr id="2" name="Title 1"/>
+          <p:cNvSpPr>
+            <a:spLocks noGrp="1"/>
+          </p:cNvSpPr>
+          <p:nvPr>
+            <p:ph type="title"/>
+          </p:nvPr>
+        </p:nvSpPr>
+        <p:spPr/>
+        <p:txBody>
+          <a:bodyPr/>
+          <a:lstStyle/>
+          <a:p>
+            <a:r>
+              <a:t>Cost-Benefit Step 1: Start With the Flagged Group</a:t>
+            </a:r>
+          </a:p>
+        </p:txBody>
+      </p:sp>
+      <p:sp>
+        <p:nvSpPr>
+          <p:cNvPr id="3" name="Content Placeholder 2"/>
+          <p:cNvSpPr>
+            <a:spLocks noGrp="1"/>
+          </p:cNvSpPr>
+          <p:nvPr>
+            <p:ph idx="1"/>
+          </p:nvPr>
+        </p:nvSpPr>
+        <p:spPr/>
+        <p:txBody>
+          <a:bodyPr wrap="square"/>
+          <a:lstStyle/>
+          <a:p>
+            <a:r>
+              <a:t>The model ranks people by predicted risk.</a:t>
+            </a:r>
+          </a:p>
+          <a:p>
+            <a:r>
+              <a:t>Suppose the intervention has K = 500 available slots.</a:t>
+            </a:r>
+          </a:p>
+          <a:p>
+            <a:r>
+              <a:t>The agency assigns the intervention to the 500 highest-risk people.</a:t>
+            </a:r>
+          </a:p>
+          <a:p>
+            <a:r>
+              <a:t>Among those 500 people, 65 become shooting victims without the intervention.</a:t>
+            </a:r>
+          </a:p>
+          <a:p>
+            <a:r>
+              <a:t>That number, 65, is the risk we are trying to reduce.</a:t>
+            </a:r>
+          </a:p>
+        </p:txBody>
+      </p:sp>
+    </p:spTree>
+  </p:cSld>
+  <p:clrMapOvr>
+    <a:masterClrMapping/>
+  </p:clrMapOvr>
+</p:sld>
+</file>
+
+<file path=ppt/slides/slide44.xml><?xml version="1.0" encoding="utf-8"?>
+<p:sld xmlns:a="http://schemas.openxmlformats.org/drawingml/2006/main" xmlns:r="http://schemas.openxmlformats.org/officeDocument/2006/relationships" xmlns:p="http://schemas.openxmlformats.org/presentationml/2006/main">
+  <p:cSld>
+    <p:spTree>
+      <p:nvGrpSpPr>
+        <p:cNvPr id="1" name=""/>
+        <p:cNvGrpSpPr/>
+        <p:nvPr/>
+      </p:nvGrpSpPr>
+      <p:grpSpPr>
+        <a:xfrm>
+          <a:off x="0" y="0"/>
+          <a:ext cx="0" cy="0"/>
+          <a:chOff x="0" y="0"/>
+          <a:chExt cx="0" cy="0"/>
+        </a:xfrm>
+      </p:grpSpPr>
+      <p:sp>
+        <p:nvSpPr>
+          <p:cNvPr id="2" name="Title 1"/>
+          <p:cNvSpPr>
+            <a:spLocks noGrp="1"/>
+          </p:cNvSpPr>
+          <p:nvPr>
+            <p:ph type="title"/>
+          </p:nvPr>
+        </p:nvSpPr>
+        <p:spPr/>
+        <p:txBody>
+          <a:bodyPr/>
+          <a:lstStyle/>
+          <a:p>
+            <a:r>
+              <a:t>Cost-Benefit Step 2: Estimate Prevented Harm</a:t>
+            </a:r>
+          </a:p>
+        </p:txBody>
+      </p:sp>
+      <p:sp>
+        <p:nvSpPr>
+          <p:cNvPr id="3" name="Content Placeholder 2"/>
+          <p:cNvSpPr>
+            <a:spLocks noGrp="1"/>
+          </p:cNvSpPr>
+          <p:nvPr>
+            <p:ph idx="1"/>
+          </p:nvPr>
+        </p:nvSpPr>
+        <p:spPr/>
+        <p:txBody>
+          <a:bodyPr wrap="square"/>
+          <a:lstStyle/>
+          <a:p>
+            <a:r>
+              <a:t>Assume the intervention reduces shooting victimization by 50%.</a:t>
+            </a:r>
+          </a:p>
+          <a:p>
+            <a:r>
+              <a:t>Expected prevented victimizations = 65 × 0.50.</a:t>
+            </a:r>
+          </a:p>
+          <a:p>
+            <a:r>
+              <a:t>65 × 0.50 = 32.5.</a:t>
+            </a:r>
+          </a:p>
+          <a:p>
+            <a:r>
+              <a:t>Round to about 33 prevented victimizations.</a:t>
+            </a:r>
+          </a:p>
+          <a:p>
+            <a:r>
+              <a:t>This is the expected benefit before converting to dollars.</a:t>
+            </a:r>
+          </a:p>
+        </p:txBody>
+      </p:sp>
+    </p:spTree>
+  </p:cSld>
+  <p:clrMapOvr>
+    <a:masterClrMapping/>
+  </p:clrMapOvr>
+</p:sld>
+</file>
+
+<file path=ppt/slides/slide45.xml><?xml version="1.0" encoding="utf-8"?>
+<p:sld xmlns:a="http://schemas.openxmlformats.org/drawingml/2006/main" xmlns:r="http://schemas.openxmlformats.org/officeDocument/2006/relationships" xmlns:p="http://schemas.openxmlformats.org/presentationml/2006/main">
+  <p:cSld>
+    <p:spTree>
+      <p:nvGrpSpPr>
+        <p:cNvPr id="1" name=""/>
+        <p:cNvGrpSpPr/>
+        <p:nvPr/>
+      </p:nvGrpSpPr>
+      <p:grpSpPr>
+        <a:xfrm>
+          <a:off x="0" y="0"/>
+          <a:ext cx="0" cy="0"/>
+          <a:chOff x="0" y="0"/>
+          <a:chExt cx="0" cy="0"/>
+        </a:xfrm>
+      </p:grpSpPr>
+      <p:sp>
+        <p:nvSpPr>
+          <p:cNvPr id="2" name="Title 1"/>
+          <p:cNvSpPr>
+            <a:spLocks noGrp="1"/>
+          </p:cNvSpPr>
+          <p:nvPr>
+            <p:ph type="title"/>
+          </p:nvPr>
+        </p:nvSpPr>
+        <p:spPr/>
+        <p:txBody>
+          <a:bodyPr/>
+          <a:lstStyle/>
+          <a:p>
+            <a:r>
+              <a:t>Cost-Benefit Step 3: Convert Benefits to Dollars</a:t>
+            </a:r>
+          </a:p>
+        </p:txBody>
+      </p:sp>
+      <p:sp>
+        <p:nvSpPr>
+          <p:cNvPr id="3" name="Content Placeholder 2"/>
+          <p:cNvSpPr>
+            <a:spLocks noGrp="1"/>
+          </p:cNvSpPr>
+          <p:nvPr>
+            <p:ph idx="1"/>
+          </p:nvPr>
+        </p:nvSpPr>
+        <p:spPr/>
+        <p:txBody>
+          <a:bodyPr wrap="square"/>
+          <a:lstStyle/>
+          <a:p>
+            <a:r>
+              <a:t>Assume each prevented victimization-year is worth $100,000.</a:t>
+            </a:r>
+          </a:p>
+          <a:p>
+            <a:r>
+              <a:t>One-year benefit = 33 × $100,000 = $3.3 million.</a:t>
+            </a:r>
+          </a:p>
+          <a:p>
+            <a:r>
+              <a:t>Three-year benefit = 33 × $100,000 × 3 = $9.9 million.</a:t>
+            </a:r>
+          </a:p>
+          <a:p>
+            <a:r>
+              <a:t>The longer the benefit lasts, the larger the estimated social benefit.</a:t>
+            </a:r>
+          </a:p>
+        </p:txBody>
+      </p:sp>
+    </p:spTree>
+  </p:cSld>
+  <p:clrMapOvr>
+    <a:masterClrMapping/>
+  </p:clrMapOvr>
+</p:sld>
+</file>
+
+<file path=ppt/slides/slide46.xml><?xml version="1.0" encoding="utf-8"?>
+<p:sld xmlns:a="http://schemas.openxmlformats.org/drawingml/2006/main" xmlns:r="http://schemas.openxmlformats.org/officeDocument/2006/relationships" xmlns:p="http://schemas.openxmlformats.org/presentationml/2006/main">
+  <p:cSld>
+    <p:spTree>
+      <p:nvGrpSpPr>
+        <p:cNvPr id="1" name=""/>
+        <p:cNvGrpSpPr/>
+        <p:nvPr/>
+      </p:nvGrpSpPr>
+      <p:grpSpPr>
+        <a:xfrm>
+          <a:off x="0" y="0"/>
+          <a:ext cx="0" cy="0"/>
+          <a:chOff x="0" y="0"/>
+          <a:chExt cx="0" cy="0"/>
+        </a:xfrm>
+      </p:grpSpPr>
+      <p:sp>
+        <p:nvSpPr>
+          <p:cNvPr id="2" name="Title 1"/>
+          <p:cNvSpPr>
+            <a:spLocks noGrp="1"/>
+          </p:cNvSpPr>
+          <p:nvPr>
+            <p:ph type="title"/>
+          </p:nvPr>
+        </p:nvSpPr>
+        <p:spPr/>
+        <p:txBody>
+          <a:bodyPr/>
+          <a:lstStyle/>
+          <a:p>
+            <a:r>
+              <a:t>Cost-Benefit Step 4: Compare Benefits to Costs</a:t>
+            </a:r>
+          </a:p>
+        </p:txBody>
+      </p:sp>
+      <p:sp>
+        <p:nvSpPr>
+          <p:cNvPr id="3" name="Content Placeholder 2"/>
+          <p:cNvSpPr>
+            <a:spLocks noGrp="1"/>
+          </p:cNvSpPr>
+          <p:nvPr>
+            <p:ph idx="1"/>
+          </p:nvPr>
+        </p:nvSpPr>
+        <p:spPr/>
+        <p:txBody>
+          <a:bodyPr wrap="square"/>
+          <a:lstStyle/>
+          <a:p>
+            <a:r>
+              <a:t>Assume the program costs $20,000 per person.</a:t>
+            </a:r>
+          </a:p>
+          <a:p>
+            <a:r>
+              <a:t>Program cost = 500 × $20,000 = $10 million.</a:t>
+            </a:r>
+          </a:p>
+          <a:p>
+            <a:r>
+              <a:t>Net benefit, 1 year = $3.3 million − $10 million = −$6.7 million.</a:t>
+            </a:r>
+          </a:p>
+          <a:p>
+            <a:r>
+              <a:t>Net benefit, 3 years = $9.9 million − $10 million = −$0.1 million.</a:t>
+            </a:r>
+          </a:p>
+          <a:p>
+            <a:r>
+              <a:t>The recommendation depends on the assumptions about effectiveness, cost, and duration.</a:t>
+            </a:r>
+          </a:p>
+        </p:txBody>
+      </p:sp>
+    </p:spTree>
+  </p:cSld>
+  <p:clrMapOvr>
+    <a:masterClrMapping/>
+  </p:clrMapOvr>
+</p:sld>
+</file>
+
+<file path=ppt/slides/slide47.xml><?xml version="1.0" encoding="utf-8"?>
+<p:sld xmlns:a="http://schemas.openxmlformats.org/drawingml/2006/main" xmlns:r="http://schemas.openxmlformats.org/officeDocument/2006/relationships" xmlns:p="http://schemas.openxmlformats.org/presentationml/2006/main">
+  <p:cSld>
+    <p:spTree>
+      <p:nvGrpSpPr>
+        <p:cNvPr id="1" name=""/>
+        <p:cNvGrpSpPr/>
+        <p:nvPr/>
+      </p:nvGrpSpPr>
+      <p:grpSpPr>
+        <a:xfrm>
+          <a:off x="0" y="0"/>
+          <a:ext cx="0" cy="0"/>
+          <a:chOff x="0" y="0"/>
+          <a:chExt cx="0" cy="0"/>
+        </a:xfrm>
+      </p:grpSpPr>
+      <p:sp>
+        <p:nvSpPr>
+          <p:cNvPr id="2" name="Title 1">
+            <a:extLst>
+              <a:ext uri="{FF2B5EF4-FFF2-40B4-BE49-F238E27FC236}">
                 <a16:creationId xmlns:a16="http://schemas.microsoft.com/office/drawing/2014/main" id="{28ACAE56-DE3D-415E-B819-9A639D63DB1E}"/>
               </a:ext>
             </a:extLst>
@@ -13584,7 +14352,7 @@
 </p:sld>
 </file>
 
-<file path=ppt/slides/slide41.xml><?xml version="1.0" encoding="utf-8"?>
+<file path=ppt/slides/slide48.xml><?xml version="1.0" encoding="utf-8"?>
 <p:sld xmlns:a="http://schemas.openxmlformats.org/drawingml/2006/main" xmlns:p="http://schemas.openxmlformats.org/presentationml/2006/main" xmlns:r="http://schemas.openxmlformats.org/officeDocument/2006/relationships">
   <p:cSld>
     <p:spTree>
@@ -13610,7 +14378,7 @@
           <a:lstStyle/>
           <a:p>
             <a:r>
-              <a:t>Cost-Benefit Step 1: Start With the Flagged Group</a:t>
+              <a:t>Assessing Algorithms vs. Assessing Impact</a:t>
             </a:r>
           </a:p>
         </p:txBody>
@@ -13632,31 +14400,25 @@
           <a:p>
             <a:pPr/>
             <a:r>
-              <a:t>The model ranks people by predicted risk.</a:t>
+              <a:t>In the clean setting, we evaluate predictions against observed outcomes.</a:t>
             </a:r>
           </a:p>
           <a:p>
             <a:pPr/>
             <a:r>
-              <a:t>Suppose the intervention has K = 500 available slots.</a:t>
+              <a:t>We compute AUC, precision, calibration, and fairness metrics.</a:t>
             </a:r>
           </a:p>
           <a:p>
             <a:pPr/>
             <a:r>
-              <a:t>The agency assigns the intervention to the 500 highest-risk people.</a:t>
+              <a:t>But real-world systems raise a second question:</a:t>
             </a:r>
           </a:p>
           <a:p>
             <a:pPr/>
             <a:r>
-              <a:t>Among those 500 people, 65 become shooting victims without the intervention.</a:t>
-            </a:r>
-          </a:p>
-          <a:p>
-            <a:pPr/>
-            <a:r>
-              <a:t>That number, 65, is the risk we are trying to reduce.</a:t>
+              <a:t>What happens when the algorithm is used to make a decision?</a:t>
             </a:r>
           </a:p>
         </p:txBody>
@@ -13669,7 +14431,7 @@
 </p:sld>
 </file>
 
-<file path=ppt/slides/slide42.xml><?xml version="1.0" encoding="utf-8"?>
+<file path=ppt/slides/slide49.xml><?xml version="1.0" encoding="utf-8"?>
 <p:sld xmlns:a="http://schemas.openxmlformats.org/drawingml/2006/main" xmlns:p="http://schemas.openxmlformats.org/presentationml/2006/main" xmlns:r="http://schemas.openxmlformats.org/officeDocument/2006/relationships">
   <p:cSld>
     <p:spTree>
@@ -13695,7 +14457,7 @@
           <a:lstStyle/>
           <a:p>
             <a:r>
-              <a:t>Cost-Benefit Step 2: Estimate Prevented Harm</a:t>
+              <a:t>Two Real-World Evaluation Problems</a:t>
             </a:r>
           </a:p>
         </p:txBody>
@@ -13717,195 +14479,25 @@
           <a:p>
             <a:pPr/>
             <a:r>
-              <a:t>Assume the intervention reduces shooting victimization by 50%.</a:t>
+              <a:t>Problem 1: Selective labels.</a:t>
             </a:r>
           </a:p>
           <a:p>
             <a:pPr/>
             <a:r>
-              <a:t>Expected prevented victimizations = 65 × 0.50.</a:t>
+              <a:t>We want to assess the algorithm, but the outcome data are biased or incomplete.</a:t>
             </a:r>
           </a:p>
           <a:p>
             <a:pPr/>
             <a:r>
-              <a:t>65 × 0.50 = 32.5.</a:t>
+              <a:t>Problem 2: Real-world impact.</a:t>
             </a:r>
           </a:p>
           <a:p>
             <a:pPr/>
             <a:r>
-              <a:t>Round to about 33 prevented victimizations.</a:t>
-            </a:r>
-          </a:p>
-          <a:p>
-            <a:pPr/>
-            <a:r>
-              <a:t>This is the expected benefit before converting to dollars.</a:t>
-            </a:r>
-          </a:p>
-        </p:txBody>
-      </p:sp>
-    </p:spTree>
-  </p:cSld>
-  <p:clrMapOvr>
-    <a:masterClrMapping/>
-  </p:clrMapOvr>
-</p:sld>
-</file>
-
-<file path=ppt/slides/slide43.xml><?xml version="1.0" encoding="utf-8"?>
-<p:sld xmlns:a="http://schemas.openxmlformats.org/drawingml/2006/main" xmlns:p="http://schemas.openxmlformats.org/presentationml/2006/main" xmlns:r="http://schemas.openxmlformats.org/officeDocument/2006/relationships">
-  <p:cSld>
-    <p:spTree>
-      <p:nvGrpSpPr>
-        <p:cNvPr id="1" name=""/>
-        <p:cNvGrpSpPr/>
-        <p:nvPr/>
-      </p:nvGrpSpPr>
-      <p:grpSpPr/>
-      <p:sp>
-        <p:nvSpPr>
-          <p:cNvPr id="2" name="Title 1"/>
-          <p:cNvSpPr>
-            <a:spLocks noGrp="1"/>
-          </p:cNvSpPr>
-          <p:nvPr>
-            <p:ph type="title"/>
-          </p:nvPr>
-        </p:nvSpPr>
-        <p:spPr/>
-        <p:txBody>
-          <a:bodyPr/>
-          <a:lstStyle/>
-          <a:p>
-            <a:r>
-              <a:t>Cost-Benefit Step 3: Convert Benefits to Dollars</a:t>
-            </a:r>
-          </a:p>
-        </p:txBody>
-      </p:sp>
-      <p:sp>
-        <p:nvSpPr>
-          <p:cNvPr id="3" name="Content Placeholder 2"/>
-          <p:cNvSpPr>
-            <a:spLocks noGrp="1"/>
-          </p:cNvSpPr>
-          <p:nvPr>
-            <p:ph idx="1"/>
-          </p:nvPr>
-        </p:nvSpPr>
-        <p:spPr/>
-        <p:txBody>
-          <a:bodyPr wrap="square"/>
-          <a:lstStyle/>
-          <a:p>
-            <a:pPr/>
-            <a:r>
-              <a:t>Assume each prevented victimization-year is worth $100,000.</a:t>
-            </a:r>
-          </a:p>
-          <a:p>
-            <a:pPr/>
-            <a:r>
-              <a:t>One-year benefit = 33 × $100,000 = $3.3 million.</a:t>
-            </a:r>
-          </a:p>
-          <a:p>
-            <a:pPr/>
-            <a:r>
-              <a:t>Three-year benefit = 33 × $100,000 × 3 = $9.9 million.</a:t>
-            </a:r>
-          </a:p>
-          <a:p>
-            <a:pPr/>
-            <a:r>
-              <a:t>The longer the benefit lasts, the larger the estimated social benefit.</a:t>
-            </a:r>
-          </a:p>
-        </p:txBody>
-      </p:sp>
-    </p:spTree>
-  </p:cSld>
-  <p:clrMapOvr>
-    <a:masterClrMapping/>
-  </p:clrMapOvr>
-</p:sld>
-</file>
-
-<file path=ppt/slides/slide44.xml><?xml version="1.0" encoding="utf-8"?>
-<p:sld xmlns:a="http://schemas.openxmlformats.org/drawingml/2006/main" xmlns:p="http://schemas.openxmlformats.org/presentationml/2006/main" xmlns:r="http://schemas.openxmlformats.org/officeDocument/2006/relationships">
-  <p:cSld>
-    <p:spTree>
-      <p:nvGrpSpPr>
-        <p:cNvPr id="1" name=""/>
-        <p:cNvGrpSpPr/>
-        <p:nvPr/>
-      </p:nvGrpSpPr>
-      <p:grpSpPr/>
-      <p:sp>
-        <p:nvSpPr>
-          <p:cNvPr id="2" name="Title 1"/>
-          <p:cNvSpPr>
-            <a:spLocks noGrp="1"/>
-          </p:cNvSpPr>
-          <p:nvPr>
-            <p:ph type="title"/>
-          </p:nvPr>
-        </p:nvSpPr>
-        <p:spPr/>
-        <p:txBody>
-          <a:bodyPr/>
-          <a:lstStyle/>
-          <a:p>
-            <a:r>
-              <a:t>Cost-Benefit Step 4: Compare Benefits to Costs</a:t>
-            </a:r>
-          </a:p>
-        </p:txBody>
-      </p:sp>
-      <p:sp>
-        <p:nvSpPr>
-          <p:cNvPr id="3" name="Content Placeholder 2"/>
-          <p:cNvSpPr>
-            <a:spLocks noGrp="1"/>
-          </p:cNvSpPr>
-          <p:nvPr>
-            <p:ph idx="1"/>
-          </p:nvPr>
-        </p:nvSpPr>
-        <p:spPr/>
-        <p:txBody>
-          <a:bodyPr wrap="square"/>
-          <a:lstStyle/>
-          <a:p>
-            <a:pPr/>
-            <a:r>
-              <a:t>Assume the program costs $20,000 per person.</a:t>
-            </a:r>
-          </a:p>
-          <a:p>
-            <a:pPr/>
-            <a:r>
-              <a:t>Program cost = 500 × $20,000 = $10 million.</a:t>
-            </a:r>
-          </a:p>
-          <a:p>
-            <a:pPr/>
-            <a:r>
-              <a:t>Net benefit, 1 year = $3.3 million − $10 million = −$6.7 million.</a:t>
-            </a:r>
-          </a:p>
-          <a:p>
-            <a:pPr/>
-            <a:r>
-              <a:t>Net benefit, 3 years = $9.9 million − $10 million = −$0.1 million.</a:t>
-            </a:r>
-          </a:p>
-          <a:p>
-            <a:pPr/>
-            <a:r>
-              <a:t>The recommendation depends on the assumptions about effectiveness, cost, and duration.</a:t>
+              <a:t>We want to assess what changes when the algorithm targets an intervention.</a:t>
             </a:r>
           </a:p>
         </p:txBody>
@@ -14411,6 +15003,328 @@
       </p:transition>
     </mc:Fallback>
   </mc:AlternateContent>
+</p:sld>
+</file>
+
+<file path=ppt/slides/slide50.xml><?xml version="1.0" encoding="utf-8"?>
+<p:sld xmlns:a="http://schemas.openxmlformats.org/drawingml/2006/main" xmlns:p="http://schemas.openxmlformats.org/presentationml/2006/main" xmlns:r="http://schemas.openxmlformats.org/officeDocument/2006/relationships">
+  <p:cSld>
+    <p:spTree>
+      <p:nvGrpSpPr>
+        <p:cNvPr id="1" name=""/>
+        <p:cNvGrpSpPr/>
+        <p:nvPr/>
+      </p:nvGrpSpPr>
+      <p:grpSpPr/>
+      <p:sp>
+        <p:nvSpPr>
+          <p:cNvPr id="2" name="Title 1"/>
+          <p:cNvSpPr>
+            <a:spLocks noGrp="1"/>
+          </p:cNvSpPr>
+          <p:nvPr>
+            <p:ph type="title"/>
+          </p:nvPr>
+        </p:nvSpPr>
+        <p:spPr/>
+        <p:txBody>
+          <a:bodyPr/>
+          <a:lstStyle/>
+          <a:p>
+            <a:r>
+              <a:t>Problem 1: Selective Labels</a:t>
+            </a:r>
+          </a:p>
+        </p:txBody>
+      </p:sp>
+      <p:sp>
+        <p:nvSpPr>
+          <p:cNvPr id="3" name="Content Placeholder 2"/>
+          <p:cNvSpPr>
+            <a:spLocks noGrp="1"/>
+          </p:cNvSpPr>
+          <p:nvPr>
+            <p:ph idx="1"/>
+          </p:nvPr>
+        </p:nvSpPr>
+        <p:spPr/>
+        <p:txBody>
+          <a:bodyPr wrap="square"/>
+          <a:lstStyle/>
+          <a:p>
+            <a:pPr/>
+            <a:r>
+              <a:t>The algorithm predicts an outcome.</a:t>
+            </a:r>
+          </a:p>
+          <a:p>
+            <a:pPr/>
+            <a:r>
+              <a:t>But the outcome is observed only for some people.</a:t>
+            </a:r>
+          </a:p>
+          <a:p>
+            <a:pPr/>
+            <a:r>
+              <a:t>Example: if judges detain high-risk defendants, we do not observe whether they would have failed to appear if released.</a:t>
+            </a:r>
+          </a:p>
+          <a:p>
+            <a:pPr/>
+            <a:r>
+              <a:t>The question is whether our estimate of model performance is trustworthy.</a:t>
+            </a:r>
+          </a:p>
+        </p:txBody>
+      </p:sp>
+    </p:spTree>
+  </p:cSld>
+  <p:clrMapOvr>
+    <a:masterClrMapping/>
+  </p:clrMapOvr>
+</p:sld>
+</file>
+
+<file path=ppt/slides/slide51.xml><?xml version="1.0" encoding="utf-8"?>
+<p:sld xmlns:a="http://schemas.openxmlformats.org/drawingml/2006/main" xmlns:p="http://schemas.openxmlformats.org/presentationml/2006/main" xmlns:r="http://schemas.openxmlformats.org/officeDocument/2006/relationships">
+  <p:cSld>
+    <p:spTree>
+      <p:nvGrpSpPr>
+        <p:cNvPr id="1" name=""/>
+        <p:cNvGrpSpPr/>
+        <p:nvPr/>
+      </p:nvGrpSpPr>
+      <p:grpSpPr/>
+      <p:sp>
+        <p:nvSpPr>
+          <p:cNvPr id="2" name="Title 1"/>
+          <p:cNvSpPr>
+            <a:spLocks noGrp="1"/>
+          </p:cNvSpPr>
+          <p:nvPr>
+            <p:ph type="title"/>
+          </p:nvPr>
+        </p:nvSpPr>
+        <p:spPr/>
+        <p:txBody>
+          <a:bodyPr/>
+          <a:lstStyle/>
+          <a:p>
+            <a:r>
+              <a:t>Problem 2: Real-World Impact</a:t>
+            </a:r>
+          </a:p>
+        </p:txBody>
+      </p:sp>
+      <p:sp>
+        <p:nvSpPr>
+          <p:cNvPr id="3" name="Content Placeholder 2"/>
+          <p:cNvSpPr>
+            <a:spLocks noGrp="1"/>
+          </p:cNvSpPr>
+          <p:nvPr>
+            <p:ph idx="1"/>
+          </p:nvPr>
+        </p:nvSpPr>
+        <p:spPr/>
+        <p:txBody>
+          <a:bodyPr wrap="square"/>
+          <a:lstStyle/>
+          <a:p>
+            <a:pPr/>
+            <a:r>
+              <a:t>The algorithm ranks people by risk.</a:t>
+            </a:r>
+          </a:p>
+          <a:p>
+            <a:pPr/>
+            <a:r>
+              <a:t>The agency uses that ranking to decide who receives an intervention.</a:t>
+            </a:r>
+          </a:p>
+          <a:p>
+            <a:pPr/>
+            <a:r>
+              <a:t>The intervention may reduce the outcome.</a:t>
+            </a:r>
+          </a:p>
+          <a:p>
+            <a:pPr/>
+            <a:r>
+              <a:t>The question is whether using the model improves outcomes enough to justify the costs.</a:t>
+            </a:r>
+          </a:p>
+        </p:txBody>
+      </p:sp>
+    </p:spTree>
+  </p:cSld>
+  <p:clrMapOvr>
+    <a:masterClrMapping/>
+  </p:clrMapOvr>
+</p:sld>
+</file>
+
+<file path=ppt/slides/slide52.xml><?xml version="1.0" encoding="utf-8"?>
+<p:sld xmlns:a="http://schemas.openxmlformats.org/drawingml/2006/main" xmlns:p="http://schemas.openxmlformats.org/presentationml/2006/main" xmlns:r="http://schemas.openxmlformats.org/officeDocument/2006/relationships">
+  <p:cSld>
+    <p:spTree>
+      <p:nvGrpSpPr>
+        <p:cNvPr id="1" name=""/>
+        <p:cNvGrpSpPr/>
+        <p:nvPr/>
+      </p:nvGrpSpPr>
+      <p:grpSpPr/>
+      <p:sp>
+        <p:nvSpPr>
+          <p:cNvPr id="2" name="Title 1"/>
+          <p:cNvSpPr>
+            <a:spLocks noGrp="1"/>
+          </p:cNvSpPr>
+          <p:nvPr>
+            <p:ph type="title"/>
+          </p:nvPr>
+        </p:nvSpPr>
+        <p:spPr/>
+        <p:txBody>
+          <a:bodyPr/>
+          <a:lstStyle/>
+          <a:p>
+            <a:r>
+              <a:t>The Policy Chain</a:t>
+            </a:r>
+          </a:p>
+        </p:txBody>
+      </p:sp>
+      <p:sp>
+        <p:nvSpPr>
+          <p:cNvPr id="3" name="Content Placeholder 2"/>
+          <p:cNvSpPr>
+            <a:spLocks noGrp="1"/>
+          </p:cNvSpPr>
+          <p:nvPr>
+            <p:ph idx="1"/>
+          </p:nvPr>
+        </p:nvSpPr>
+        <p:spPr/>
+        <p:txBody>
+          <a:bodyPr wrap="square"/>
+          <a:lstStyle/>
+          <a:p>
+            <a:pPr/>
+            <a:r>
+              <a:t>Build a prediction model.</a:t>
+            </a:r>
+          </a:p>
+          <a:p>
+            <a:pPr/>
+            <a:r>
+              <a:t>Rank people by predicted risk.</a:t>
+            </a:r>
+          </a:p>
+          <a:p>
+            <a:pPr/>
+            <a:r>
+              <a:t>Target an intervention to the highest-risk group.</a:t>
+            </a:r>
+          </a:p>
+          <a:p>
+            <a:pPr/>
+            <a:r>
+              <a:t>Estimate how much the intervention changes outcomes.</a:t>
+            </a:r>
+          </a:p>
+          <a:p>
+            <a:pPr/>
+            <a:r>
+              <a:t>Compare prevented outcomes to program costs.</a:t>
+            </a:r>
+          </a:p>
+        </p:txBody>
+      </p:sp>
+    </p:spTree>
+  </p:cSld>
+  <p:clrMapOvr>
+    <a:masterClrMapping/>
+  </p:clrMapOvr>
+</p:sld>
+</file>
+
+<file path=ppt/slides/slide53.xml><?xml version="1.0" encoding="utf-8"?>
+<p:sld xmlns:a="http://schemas.openxmlformats.org/drawingml/2006/main" xmlns:p="http://schemas.openxmlformats.org/presentationml/2006/main" xmlns:r="http://schemas.openxmlformats.org/officeDocument/2006/relationships">
+  <p:cSld>
+    <p:spTree>
+      <p:nvGrpSpPr>
+        <p:cNvPr id="1" name=""/>
+        <p:cNvGrpSpPr/>
+        <p:nvPr/>
+      </p:nvGrpSpPr>
+      <p:grpSpPr/>
+      <p:sp>
+        <p:nvSpPr>
+          <p:cNvPr id="2" name="Title 1"/>
+          <p:cNvSpPr>
+            <a:spLocks noGrp="1"/>
+          </p:cNvSpPr>
+          <p:nvPr>
+            <p:ph type="title"/>
+          </p:nvPr>
+        </p:nvSpPr>
+        <p:spPr/>
+        <p:txBody>
+          <a:bodyPr/>
+          <a:lstStyle/>
+          <a:p>
+            <a:r>
+              <a:t>Where Cost-Benefit Analysis Enters</a:t>
+            </a:r>
+          </a:p>
+        </p:txBody>
+      </p:sp>
+      <p:sp>
+        <p:nvSpPr>
+          <p:cNvPr id="3" name="Content Placeholder 2"/>
+          <p:cNvSpPr>
+            <a:spLocks noGrp="1"/>
+          </p:cNvSpPr>
+          <p:nvPr>
+            <p:ph idx="1"/>
+          </p:nvPr>
+        </p:nvSpPr>
+        <p:spPr/>
+        <p:txBody>
+          <a:bodyPr wrap="square"/>
+          <a:lstStyle/>
+          <a:p>
+            <a:pPr/>
+            <a:r>
+              <a:t>Prediction tells us who is high risk.</a:t>
+            </a:r>
+          </a:p>
+          <a:p>
+            <a:pPr/>
+            <a:r>
+              <a:t>The treatment effect tells us how much risk falls after intervention.</a:t>
+            </a:r>
+          </a:p>
+          <a:p>
+            <a:pPr/>
+            <a:r>
+              <a:t>Cost-benefit analysis combines risk, treatment effects, outcome values, and program costs.</a:t>
+            </a:r>
+          </a:p>
+          <a:p>
+            <a:pPr/>
+            <a:r>
+              <a:t>For this lecture and the final project, we will treat the treatment effect as an assumption.</a:t>
+            </a:r>
+          </a:p>
+        </p:txBody>
+      </p:sp>
+    </p:spTree>
+  </p:cSld>
+  <p:clrMapOvr>
+    <a:masterClrMapping/>
+  </p:clrMapOvr>
 </p:sld>
 </file>
 

</xml_diff>